<commit_message>
Modificats Burndown Chart i presentació dilluns
</commit_message>
<xml_diff>
--- a/documents/Sprint4/Sprint_Review4_431-2.pptx
+++ b/documents/Sprint4/Sprint_Review4_431-2.pptx
@@ -246,7 +246,7 @@
           <a:p>
             <a:fld id="{F79ECDAD-75E1-4BC4-AB86-9BA5DFF857B3}" type="datetimeFigureOut">
               <a:rPr lang="en-GB" smtClean="0"/>
-              <a:t>31/05/2026</a:t>
+              <a:t>01/06/2026</a:t>
             </a:fld>
             <a:endParaRPr lang="en-GB"/>
           </a:p>
@@ -846,7 +846,7 @@
           <a:p>
             <a:fld id="{31DCF8F9-FE1E-467E-9B82-0FEB758F2FA6}" type="datetime1">
               <a:rPr lang="en-US" smtClean="0"/>
-              <a:t>5/31/2026</a:t>
+              <a:t>6/1/2026</a:t>
             </a:fld>
             <a:endParaRPr lang="en-US" dirty="0"/>
           </a:p>
@@ -1216,7 +1216,7 @@
           <a:p>
             <a:fld id="{5CAAE393-D011-4B55-A9B6-0BBC79EF96B0}" type="datetime1">
               <a:rPr lang="en-US" smtClean="0"/>
-              <a:t>5/31/2026</a:t>
+              <a:t>6/1/2026</a:t>
             </a:fld>
             <a:endParaRPr lang="en-US"/>
           </a:p>
@@ -1425,7 +1425,7 @@
           <a:p>
             <a:fld id="{8ACD0C2F-F497-4247-8BB2-5746400D850B}" type="datetime1">
               <a:rPr lang="en-US" smtClean="0"/>
-              <a:t>5/31/2026</a:t>
+              <a:t>6/1/2026</a:t>
             </a:fld>
             <a:endParaRPr lang="en-US"/>
           </a:p>
@@ -1895,7 +1895,7 @@
           <a:p>
             <a:fld id="{6219CF75-0ECC-4E76-B636-3ABF46261502}" type="datetime1">
               <a:rPr lang="en-US" smtClean="0"/>
-              <a:t>5/31/2026</a:t>
+              <a:t>6/1/2026</a:t>
             </a:fld>
             <a:endParaRPr lang="en-US"/>
           </a:p>
@@ -2349,7 +2349,7 @@
           <a:p>
             <a:fld id="{8D14E8BD-E6E8-42B0-9E1C-58D2F9C64A0C}" type="datetime1">
               <a:rPr lang="en-US" smtClean="0"/>
-              <a:t>5/31/2026</a:t>
+              <a:t>6/1/2026</a:t>
             </a:fld>
             <a:endParaRPr lang="en-US"/>
           </a:p>
@@ -2881,7 +2881,7 @@
           <a:p>
             <a:fld id="{D7AFBA47-0BC8-4C75-9B10-88B9F496CCB1}" type="datetime1">
               <a:rPr lang="en-US" smtClean="0"/>
-              <a:t>5/31/2026</a:t>
+              <a:t>6/1/2026</a:t>
             </a:fld>
             <a:endParaRPr lang="en-US"/>
           </a:p>
@@ -3580,7 +3580,7 @@
           <a:p>
             <a:fld id="{84512E72-AC33-43BA-BEE9-4FD4948C58D8}" type="datetime1">
               <a:rPr lang="en-US" smtClean="0"/>
-              <a:t>5/31/2026</a:t>
+              <a:t>6/1/2026</a:t>
             </a:fld>
             <a:endParaRPr lang="en-US"/>
           </a:p>
@@ -3909,7 +3909,7 @@
           <a:p>
             <a:fld id="{CB376718-59A8-49B1-AEC5-3662572A144D}" type="datetime1">
               <a:rPr lang="en-US" smtClean="0"/>
-              <a:t>5/31/2026</a:t>
+              <a:t>6/1/2026</a:t>
             </a:fld>
             <a:endParaRPr lang="en-US"/>
           </a:p>
@@ -4022,7 +4022,7 @@
           <a:p>
             <a:fld id="{284EC767-5C82-4733-81D6-0B6B22CAF0EE}" type="datetime1">
               <a:rPr lang="en-US" smtClean="0"/>
-              <a:t>5/31/2026</a:t>
+              <a:t>6/1/2026</a:t>
             </a:fld>
             <a:endParaRPr lang="en-US"/>
           </a:p>
@@ -4517,7 +4517,7 @@
           <a:p>
             <a:fld id="{E4D41E06-6C86-4754-846D-56519DFF1F50}" type="datetime1">
               <a:rPr lang="en-US" smtClean="0"/>
-              <a:t>5/31/2026</a:t>
+              <a:t>6/1/2026</a:t>
             </a:fld>
             <a:endParaRPr lang="en-US" dirty="0"/>
           </a:p>
@@ -4994,7 +4994,7 @@
           <a:p>
             <a:fld id="{6D8A39B2-B176-40DF-B22F-280C511548AF}" type="datetime1">
               <a:rPr lang="en-US" smtClean="0"/>
-              <a:t>5/31/2026</a:t>
+              <a:t>6/1/2026</a:t>
             </a:fld>
             <a:endParaRPr lang="en-US"/>
           </a:p>
@@ -5237,7 +5237,7 @@
           <a:p>
             <a:fld id="{80BAA1BC-C245-4537-A704-02F8919D151B}" type="datetime1">
               <a:rPr lang="en-US" smtClean="0"/>
-              <a:t>5/31/2026</a:t>
+              <a:t>6/1/2026</a:t>
             </a:fld>
             <a:endParaRPr lang="en-US"/>
           </a:p>
@@ -7151,10 +7151,10 @@
       </p:sp>
       <p:pic>
         <p:nvPicPr>
-          <p:cNvPr id="7" name="Imagen 6">
-            <a:extLst>
-              <a:ext uri="{FF2B5EF4-FFF2-40B4-BE49-F238E27FC236}">
-                <a16:creationId xmlns:a16="http://schemas.microsoft.com/office/drawing/2014/main" id="{BBC79676-64B1-19F8-087E-66BBE54FE7FA}"/>
+          <p:cNvPr id="5" name="Imagen 4">
+            <a:extLst>
+              <a:ext uri="{FF2B5EF4-FFF2-40B4-BE49-F238E27FC236}">
+                <a16:creationId xmlns:a16="http://schemas.microsoft.com/office/drawing/2014/main" id="{FDEA6AA7-34CF-FDEF-28D7-B87FF386299D}"/>
               </a:ext>
             </a:extLst>
           </p:cNvPr>
@@ -7171,8 +7171,8 @@
         </p:blipFill>
         <p:spPr>
           <a:xfrm>
-            <a:off x="4071048" y="2051090"/>
-            <a:ext cx="4049903" cy="4670385"/>
+            <a:off x="2464625" y="2085541"/>
+            <a:ext cx="7262750" cy="4739802"/>
           </a:xfrm>
           <a:prstGeom prst="rect">
             <a:avLst/>
@@ -7416,11 +7416,11 @@
   <p:clrMapOvr>
     <a:masterClrMapping/>
   </p:clrMapOvr>
-  <mc:AlternateContent xmlns:mc="http://schemas.openxmlformats.org/markup-compatibility/2006">
-    <mc:Choice xmlns:p14="http://schemas.microsoft.com/office/powerpoint/2010/main" Requires="p14">
+  <mc:AlternateContent xmlns:mc="http://schemas.openxmlformats.org/markup-compatibility/2006" xmlns:p14="http://schemas.microsoft.com/office/powerpoint/2010/main">
+    <mc:Choice Requires="p14">
       <p:transition p14:dur="0" advClick="0"/>
     </mc:Choice>
-    <mc:Fallback>
+    <mc:Fallback xmlns="">
       <p:transition advClick="0"/>
     </mc:Fallback>
   </mc:AlternateContent>
@@ -15412,6 +15412,15 @@
 </file>
 
 <file path=customXml/item1.xml><?xml version="1.0" encoding="utf-8"?>
+<?mso-contentType ?>
+<FormTemplates xmlns="http://schemas.microsoft.com/sharepoint/v3/contenttype/forms">
+  <Display>DocumentLibraryForm</Display>
+  <Edit>DocumentLibraryForm</Edit>
+  <New>DocumentLibraryForm</New>
+</FormTemplates>
+</file>
+
+<file path=customXml/item2.xml><?xml version="1.0" encoding="utf-8"?>
 <ct:contentTypeSchema xmlns:ct="http://schemas.microsoft.com/office/2006/metadata/contentType" xmlns:ma="http://schemas.microsoft.com/office/2006/metadata/properties/metaAttributes" ct:_="" ma:_="" ma:contentTypeName="Documento" ma:contentTypeID="0x01010063BD3DC6F0E81D4FA56575A4B7B24AF5" ma:contentTypeVersion="14" ma:contentTypeDescription="Crear nuevo documento." ma:contentTypeScope="" ma:versionID="ded3d347f3a98b31a82ee0cc093f824b">
   <xsd:schema xmlns:xsd="http://www.w3.org/2001/XMLSchema" xmlns:xs="http://www.w3.org/2001/XMLSchema" xmlns:p="http://schemas.microsoft.com/office/2006/metadata/properties" xmlns:ns3="7b814fa0-4f1b-4d56-8a36-064af1e36e66" xmlns:ns4="b1fa7ccf-aa4f-4f27-84db-07667d020acb" targetNamespace="http://schemas.microsoft.com/office/2006/metadata/properties" ma:root="true" ma:fieldsID="fe3adeea5df1e60fd0d7c7fb86895927" ns3:_="" ns4:_="">
     <xsd:import namespace="7b814fa0-4f1b-4d56-8a36-064af1e36e66"/>
@@ -15640,7 +15649,7 @@
 </ct:contentTypeSchema>
 </file>
 
-<file path=customXml/item2.xml><?xml version="1.0" encoding="utf-8"?>
+<file path=customXml/item3.xml><?xml version="1.0" encoding="utf-8"?>
 <p:properties xmlns:p="http://schemas.microsoft.com/office/2006/metadata/properties" xmlns:xsi="http://www.w3.org/2001/XMLSchema-instance" xmlns:pc="http://schemas.microsoft.com/office/infopath/2007/PartnerControls">
   <documentManagement>
     <SharedWithUsers xmlns="7b814fa0-4f1b-4d56-8a36-064af1e36e66">
@@ -15655,16 +15664,15 @@
 </p:properties>
 </file>
 
-<file path=customXml/item3.xml><?xml version="1.0" encoding="utf-8"?>
-<?mso-contentType ?>
-<FormTemplates xmlns="http://schemas.microsoft.com/sharepoint/v3/contenttype/forms">
-  <Display>DocumentLibraryForm</Display>
-  <Edit>DocumentLibraryForm</Edit>
-  <New>DocumentLibraryForm</New>
-</FormTemplates>
+<file path=customXml/itemProps1.xml><?xml version="1.0" encoding="utf-8"?>
+<ds:datastoreItem xmlns:ds="http://schemas.openxmlformats.org/officeDocument/2006/customXml" ds:itemID="{04171512-FDE1-4E49-B7EA-58AD2B333724}">
+  <ds:schemaRefs>
+    <ds:schemaRef ds:uri="http://schemas.microsoft.com/sharepoint/v3/contenttype/forms"/>
+  </ds:schemaRefs>
+</ds:datastoreItem>
 </file>
 
-<file path=customXml/itemProps1.xml><?xml version="1.0" encoding="utf-8"?>
+<file path=customXml/itemProps2.xml><?xml version="1.0" encoding="utf-8"?>
 <ds:datastoreItem xmlns:ds="http://schemas.openxmlformats.org/officeDocument/2006/customXml" ds:itemID="{E77A2FCE-FB77-4A2D-98B9-B8BD51BEE8CE}">
   <ds:schemaRefs>
     <ds:schemaRef ds:uri="http://schemas.microsoft.com/office/2006/metadata/contentType"/>
@@ -15683,7 +15691,7 @@
 </ds:datastoreItem>
 </file>
 
-<file path=customXml/itemProps2.xml><?xml version="1.0" encoding="utf-8"?>
+<file path=customXml/itemProps3.xml><?xml version="1.0" encoding="utf-8"?>
 <ds:datastoreItem xmlns:ds="http://schemas.openxmlformats.org/officeDocument/2006/customXml" ds:itemID="{4FBF3923-D9E5-4962-BBB8-690B0ABC4F42}">
   <ds:schemaRefs>
     <ds:schemaRef ds:uri="http://www.w3.org/XML/1998/namespace"/>
@@ -15698,12 +15706,4 @@
     <ds:schemaRef ds:uri="http://purl.org/dc/terms/"/>
   </ds:schemaRefs>
 </ds:datastoreItem>
-</file>
-
-<file path=customXml/itemProps3.xml><?xml version="1.0" encoding="utf-8"?>
-<ds:datastoreItem xmlns:ds="http://schemas.openxmlformats.org/officeDocument/2006/customXml" ds:itemID="{04171512-FDE1-4E49-B7EA-58AD2B333724}">
-  <ds:schemaRefs>
-    <ds:schemaRef ds:uri="http://schemas.microsoft.com/sharepoint/v3/contenttype/forms"/>
-  </ds:schemaRefs>
-</ds:datastoreItem>
 </file>
</xml_diff>